<commit_message>
Material W4–W6, Werkzeugkarten, Lehrerhinweise, Prüfungen neu gebaut (Kontrastregel, Text unverändert)
75 Dateien aus 49 Quellen neu gebaut (Videos ausgenommen); Textvergleich gegen den Bestand: keine Änderung
außer den Wortlisten der Lehrerhinweise W3/W6 (Task 191); danach 0 Kontrast-Verstöße, Stichproben als PDF
angesehen. npm test grün.

Co-Authored-By: Claude Opus 5.5 <noreply@anthropic.com>
Claude-Session: https://claude.ai/code/session_01JKXVQqFeKVmyQ9jfHw4db3
</commit_message>
<xml_diff>
--- a/materialien/Welt4_Schluesselproblem/1_Praesentation/KR_W4_Praesentation_Stanford.pptx
+++ b/materialien/Welt4_Schluesselproblem/1_Praesentation/KR_W4_Praesentation_Stanford.pptx
@@ -134,7 +134,7 @@
   <p:extLst>
     <p:ext uri="{521415D9-36F7-43E2-AB2F-B90AF26B5E84}">
       <p14:sectionLst xmlns:p14="http://schemas.microsoft.com/office/powerpoint/2010/main">
-        <p14:section name="DS 12 · Das Schlüsselproblem" id="{0b767c1b-59f9-21ee-ef3e-045785ebc043}">
+        <p14:section name="DS 12 · Das Schlüsselproblem" id="{0f3df47b-0663-b809-9179-1f73d53e43d5}">
           <p14:sldIdLst>
             <p14:sldId id="256"/>
             <p14:sldId id="257"/>
@@ -148,7 +148,7 @@
             <p14:sldId id="265"/>
           </p14:sldIdLst>
         </p14:section>
-        <p14:section name="DS 12 · Diffie-Hellman (Ergänzung)" id="{19027951-5c51-881a-b1f7-57ecdb4a124e}">
+        <p14:section name="DS 12 · Diffie-Hellman (Ergänzung)" id="{11430400-bf38-991b-4b58-2646e8f43d63}">
           <p14:sldIdLst>
             <p14:sldId id="266"/>
             <p14:sldId id="267"/>
@@ -159,7 +159,7 @@
             <p14:sldId id="272"/>
           </p14:sldIdLst>
         </p14:section>
-        <p14:section name="DS 13 · RSA und Hybrid" id="{e20798bd-e62c-55bd-4fcf-fad1368dde5a}">
+        <p14:section name="DS 13 · RSA und Hybrid" id="{af803531-0e21-b3fa-c7da-cf87d77a8430}">
           <p14:sldIdLst>
             <p14:sldId id="273"/>
             <p14:sldId id="274"/>

</xml_diff>